<commit_message>
docs: expanded presentation (11 slides + graphs) + speech DOCX
Presentation (11 slides, 4 new with graphs):
1. Title (unchanged)
2. Actuality + Results (detailed, 11 models listed)
3. Novelty (specific numbers: 10.61% vs 13.89%)
4. Methodology (fixed vs learnable decomp explained)
5. Results heatmap (cross-dataset sMAPE visualization)
6. Forecast examples (11-model comparison plot)
7. Rollout experiment (degradation chart + numbers)
8. Pretrain experiment (improvement chart + numbers)
9. Plan-schedule
10. Conclusion (5 specific findings)
11. Thank you

Speech text (DOCX, ~4 pages):
- Continuous flowing Russian text, no headers
- Times New Roman 14pt, 1.5 spacing, justified
- All facts from thesis with exact numbers
- Explains fixed vs learnable decomposition concretely

Co-Authored-By: Claude Opus 4.6 <noreply@anthropic.com>
</commit_message>
<xml_diff>
--- a/docs/Lazarev-Presentation-VIK-25-26-updated.pptx
+++ b/docs/Lazarev-Presentation-VIK-25-26-updated.pptx
@@ -12,6 +12,10 @@
     <p:sldId id="261" r:id="rId3"/>
     <p:sldId id="268" r:id="rId4"/>
     <p:sldId id="259" r:id="rId5"/>
+    <p:sldId id="272" r:id="rId19"/>
+    <p:sldId id="275" r:id="rId22"/>
+    <p:sldId id="273" r:id="rId20"/>
+    <p:sldId id="274" r:id="rId21"/>
     <p:sldId id="262" r:id="rId6"/>
     <p:sldId id="271" r:id="rId7"/>
     <p:sldId id="267" r:id="rId8"/>
@@ -5371,7 +5375,7 @@
                   <a:schemeClr val="bg1"/>
                 </a:solidFill>
               </a:rPr>
-              <a:t>Построение комбинированных моделей на основе алгоритма </a:t>
+              <a:t xml:space="preserve">Построение комбинированных моделей на основе алгоритма </a:t>
             </a:r>
             <a:r>
               <a:rPr lang="en-US" sz="3200" dirty="0" err="1">
@@ -5387,7 +5391,7 @@
                   <a:schemeClr val="bg1"/>
                 </a:solidFill>
               </a:rPr>
-              <a:t> </a:t>
+              <a:t xml:space="preserve"> </a:t>
             </a:r>
             <a:r>
               <a:rPr lang="ru-RU" sz="3200" dirty="0">
@@ -6229,6 +6233,343 @@
         <p14:creationId xmlns:p14="http://schemas.microsoft.com/office/powerpoint/2010/main" val="473747644"/>
       </p:ext>
     </p:extLst>
+  </p:cSld>
+  <p:clrMapOvr>
+    <a:masterClrMapping/>
+  </p:clrMapOvr>
+</p:sld>
+</file>
+
+<file path=ppt/slides/slide10.xml><?xml version="1.0" encoding="utf-8"?>
+<p:sld xmlns:a="http://schemas.openxmlformats.org/drawingml/2006/main" xmlns:p="http://schemas.openxmlformats.org/presentationml/2006/main" xmlns:r="http://schemas.openxmlformats.org/officeDocument/2006/relationships">
+  <p:cSld>
+    <p:spTree>
+      <p:nvGrpSpPr>
+        <p:cNvPr id="1" name=""/>
+        <p:cNvGrpSpPr/>
+        <p:nvPr/>
+      </p:nvGrpSpPr>
+      <p:grpSpPr/>
+      <p:sp>
+        <p:nvSpPr>
+          <p:cNvPr id="2" name="Title 1"/>
+          <p:cNvSpPr>
+            <a:spLocks noGrp="1"/>
+          </p:cNvSpPr>
+          <p:nvPr>
+            <p:ph type="title"/>
+          </p:nvPr>
+        </p:nvSpPr>
+        <p:spPr/>
+        <p:txBody>
+          <a:bodyPr/>
+          <a:lstStyle/>
+          <a:p>
+            <a:r>
+              <a:rPr lang="ru-RU" dirty="0"/>
+              <a:t>Предобучение трансформеров</a:t>
+            </a:r>
+          </a:p>
+        </p:txBody>
+      </p:sp>
+      <p:sp>
+        <p:nvSpPr>
+          <p:cNvPr id="3" name="Text Placeholder 2"/>
+          <p:cNvSpPr>
+            <a:spLocks noGrp="1"/>
+          </p:cNvSpPr>
+          <p:nvPr>
+            <p:ph type="body" idx="10" sz="quarter"/>
+          </p:nvPr>
+        </p:nvSpPr>
+        <p:spPr/>
+        <p:txBody>
+          <a:bodyPr/>
+          <a:lstStyle/>
+          <a:p>
+            <a:r>
+              <a:rPr lang="ru-RU" dirty="0"/>
+              <a:t>Эффект предобучения</a:t>
+            </a:r>
+          </a:p>
+        </p:txBody>
+      </p:sp>
+      <p:sp>
+        <p:nvSpPr>
+          <p:cNvPr id="4" name="Text Placeholder 3"/>
+          <p:cNvSpPr>
+            <a:spLocks noGrp="1"/>
+          </p:cNvSpPr>
+          <p:nvPr>
+            <p:ph type="body" idx="11" sz="quarter"/>
+          </p:nvPr>
+        </p:nvSpPr>
+        <p:spPr/>
+        <p:txBody>
+          <a:bodyPr/>
+          <a:lstStyle/>
+          <a:p>
+            <a:r>
+              <a:rPr lang="ru-RU" dirty="0" sz="1100"/>
+              <a:t>Вместо обучения каждой модели</a:t>
+            </a:r>
+          </a:p>
+          <a:p>
+            <a:r>
+              <a:rPr lang="ru-RU" dirty="0" sz="1100"/>
+              <a:t>с нуля на одном ряде —</a:t>
+            </a:r>
+          </a:p>
+          <a:p>
+            <a:r>
+              <a:rPr lang="ru-RU" dirty="0" sz="1100"/>
+              <a:t>предобучение на всех 1428</a:t>
+            </a:r>
+          </a:p>
+          <a:p>
+            <a:r>
+              <a:rPr lang="ru-RU" dirty="0" sz="1100"/>
+              <a:t>месячных рядах M3 (70 тыс. окон),</a:t>
+            </a:r>
+          </a:p>
+          <a:p>
+            <a:r>
+              <a:rPr lang="ru-RU" dirty="0" sz="1100"/>
+              <a:t>затем дообучение 20 эпох.</a:t>
+            </a:r>
+          </a:p>
+          <a:p/>
+          <a:p>
+            <a:r>
+              <a:rPr lang="ru-RU" dirty="0" sz="1100"/>
+              <a:t>Улучшение sMAPE:</a:t>
+            </a:r>
+          </a:p>
+          <a:p>
+            <a:r>
+              <a:rPr lang="ru-RU" dirty="0" sz="1100"/>
+              <a:t>• PatchTST: 19,0 → 17,0 (−10,8%)</a:t>
+            </a:r>
+          </a:p>
+          <a:p>
+            <a:r>
+              <a:rPr lang="ru-RU" dirty="0" sz="1100"/>
+              <a:t>• Autoformer: 16,7 → 15,1 (−9,6%)</a:t>
+            </a:r>
+          </a:p>
+          <a:p>
+            <a:r>
+              <a:rPr lang="ru-RU" dirty="0" sz="1100"/>
+              <a:t>• FEDformer: 18,6 → 17,2 (−7,3%)</a:t>
+            </a:r>
+          </a:p>
+          <a:p/>
+          <a:p>
+            <a:r>
+              <a:rPr lang="ru-RU" dirty="0" sz="1100"/>
+              <a:t>Вывод: трансформерам критически</a:t>
+            </a:r>
+          </a:p>
+          <a:p>
+            <a:r>
+              <a:rPr lang="ru-RU" dirty="0" sz="1100"/>
+              <a:t>не хватает данных при per-series</a:t>
+            </a:r>
+          </a:p>
+          <a:p>
+            <a:r>
+              <a:rPr lang="ru-RU" dirty="0" sz="1100"/>
+              <a:t>обучении. Предобучение частично</a:t>
+            </a:r>
+          </a:p>
+          <a:p>
+            <a:r>
+              <a:rPr lang="ru-RU" dirty="0" sz="1100"/>
+              <a:t>компенсирует этот дефицит.</a:t>
+            </a:r>
+          </a:p>
+        </p:txBody>
+      </p:sp>
+      <p:pic>
+        <p:nvPicPr>
+          <p:cNvPr id="5" name="Picture Placeholder 4" descr="pretrain_m3_monthly_patchtst_T779.png"/>
+          <p:cNvPicPr>
+            <a:picLocks noGrp="1" noChangeAspect="1"/>
+          </p:cNvPicPr>
+          <p:nvPr>
+            <p:ph type="pic" idx="12" sz="quarter"/>
+          </p:nvPr>
+        </p:nvPicPr>
+        <p:blipFill>
+          <a:blip r:embed="rId2"/>
+          <a:srcRect l="26031" r="26031"/>
+          <a:stretch>
+            <a:fillRect/>
+          </a:stretch>
+        </p:blipFill>
+        <p:spPr/>
+      </p:pic>
+    </p:spTree>
+  </p:cSld>
+  <p:clrMapOvr>
+    <a:masterClrMapping/>
+  </p:clrMapOvr>
+</p:sld>
+</file>
+
+<file path=ppt/slides/slide11.xml><?xml version="1.0" encoding="utf-8"?>
+<p:sld xmlns:a="http://schemas.openxmlformats.org/drawingml/2006/main" xmlns:p="http://schemas.openxmlformats.org/presentationml/2006/main" xmlns:r="http://schemas.openxmlformats.org/officeDocument/2006/relationships">
+  <p:cSld>
+    <p:spTree>
+      <p:nvGrpSpPr>
+        <p:cNvPr id="1" name=""/>
+        <p:cNvGrpSpPr/>
+        <p:nvPr/>
+      </p:nvGrpSpPr>
+      <p:grpSpPr/>
+      <p:sp>
+        <p:nvSpPr>
+          <p:cNvPr id="2" name="Title 1"/>
+          <p:cNvSpPr>
+            <a:spLocks noGrp="1"/>
+          </p:cNvSpPr>
+          <p:nvPr>
+            <p:ph type="title"/>
+          </p:nvPr>
+        </p:nvSpPr>
+        <p:spPr/>
+        <p:txBody>
+          <a:bodyPr/>
+          <a:lstStyle/>
+          <a:p>
+            <a:r>
+              <a:rPr lang="ru-RU" dirty="0"/>
+              <a:t>Примеры прогнозов</a:t>
+            </a:r>
+          </a:p>
+        </p:txBody>
+      </p:sp>
+      <p:sp>
+        <p:nvSpPr>
+          <p:cNvPr id="3" name="Text Placeholder 2"/>
+          <p:cNvSpPr>
+            <a:spLocks noGrp="1"/>
+          </p:cNvSpPr>
+          <p:nvPr>
+            <p:ph type="body" idx="10" sz="quarter"/>
+          </p:nvPr>
+        </p:nvSpPr>
+        <p:spPr/>
+        <p:txBody>
+          <a:bodyPr/>
+          <a:lstStyle/>
+          <a:p>
+            <a:r>
+              <a:rPr lang="ru-RU" dirty="0"/>
+              <a:t>Визуальный анализ</a:t>
+            </a:r>
+          </a:p>
+        </p:txBody>
+      </p:sp>
+      <p:sp>
+        <p:nvSpPr>
+          <p:cNvPr id="4" name="Text Placeholder 3"/>
+          <p:cNvSpPr>
+            <a:spLocks noGrp="1"/>
+          </p:cNvSpPr>
+          <p:nvPr>
+            <p:ph type="body" idx="11" sz="quarter"/>
+          </p:nvPr>
+        </p:nvSpPr>
+        <p:spPr/>
+        <p:txBody>
+          <a:bodyPr/>
+          <a:lstStyle/>
+          <a:p>
+            <a:r>
+              <a:rPr lang="ru-RU" dirty="0" sz="1100"/>
+              <a:t>На графике — прогноз всех 11</a:t>
+            </a:r>
+          </a:p>
+          <a:p>
+            <a:r>
+              <a:rPr lang="ru-RU" dirty="0" sz="1100"/>
+              <a:t>моделей на квартальном ряде M3.</a:t>
+            </a:r>
+          </a:p>
+          <a:p/>
+          <a:p>
+            <a:r>
+              <a:rPr lang="ru-RU" dirty="0" sz="1100"/>
+              <a:t>Синий — обучающая выборка,</a:t>
+            </a:r>
+          </a:p>
+          <a:p>
+            <a:r>
+              <a:rPr lang="ru-RU" dirty="0" sz="1100"/>
+              <a:t>красный — тестовая (8 шагов).</a:t>
+            </a:r>
+          </a:p>
+          <a:p>
+            <a:r>
+              <a:rPr lang="ru-RU" dirty="0" sz="1100"/>
+              <a:t>Пунктир — прогнозы моделей.</a:t>
+            </a:r>
+          </a:p>
+          <a:p/>
+          <a:p>
+            <a:r>
+              <a:rPr lang="ru-RU" dirty="0" sz="1100"/>
+              <a:t>Helformer (фиолетовый) и ETS</a:t>
+            </a:r>
+          </a:p>
+          <a:p>
+            <a:r>
+              <a:rPr lang="ru-RU" dirty="0" sz="1100"/>
+              <a:t>(тёмно-синий) ближе всего</a:t>
+            </a:r>
+          </a:p>
+          <a:p>
+            <a:r>
+              <a:rPr lang="ru-RU" dirty="0" sz="1100"/>
+              <a:t>к реальным значениям.</a:t>
+            </a:r>
+          </a:p>
+          <a:p/>
+          <a:p>
+            <a:r>
+              <a:rPr lang="ru-RU" dirty="0" sz="1100"/>
+              <a:t>Autoformer и FEDformer дают</a:t>
+            </a:r>
+          </a:p>
+          <a:p>
+            <a:r>
+              <a:rPr lang="ru-RU" dirty="0" sz="1100"/>
+              <a:t>наибольшие отклонения.</a:t>
+            </a:r>
+          </a:p>
+        </p:txBody>
+      </p:sp>
+      <p:pic>
+        <p:nvPicPr>
+          <p:cNvPr id="5" name="Picture Placeholder 4" descr="m3_quarterly_T478.png"/>
+          <p:cNvPicPr>
+            <a:picLocks noGrp="1" noChangeAspect="1"/>
+          </p:cNvPicPr>
+          <p:nvPr>
+            <p:ph type="pic" idx="12" sz="quarter"/>
+          </p:nvPr>
+        </p:nvPicPr>
+        <p:blipFill>
+          <a:blip r:embed="rId2"/>
+          <a:srcRect l="27599" r="27599"/>
+          <a:stretch>
+            <a:fillRect/>
+          </a:stretch>
+        </p:blipFill>
+        <p:spPr/>
+      </p:pic>
+    </p:spTree>
   </p:cSld>
   <p:clrMapOvr>
     <a:masterClrMapping/>
@@ -6314,7 +6655,7 @@
           <a:p>
             <a:r>
               <a:rPr lang="ru-RU" dirty="0"/>
-              <a:t>Результаты исследования</a:t>
+              <a:t>Полученные результаты</a:t>
             </a:r>
           </a:p>
         </p:txBody>
@@ -6359,12 +6700,12 @@
               <a:buChar char="•"/>
             </a:pPr>
             <a:r>
-              <a:rPr lang="en-US" altLang="en-US" dirty="0" err="1">
+              <a:rPr lang="en-US" altLang="en-US" dirty="0" err="1" sz="1100">
                 <a:solidFill>
                   <a:schemeClr val="tx1"/>
                 </a:solidFill>
               </a:rPr>
-              <a:t>Реализован экспериментальный контур из 11 моделей: 4 классические (ARIMA, ETS, Prophet, Seasonal Naive), 6 нейросетевых (DLinear, N-BEATS, TimesNet, Autoformer, FEDformer, PatchTST) и гибридная Helformer.</a:t>
+              <a:t>Реализован контур из 11 моделей:</a:t>
             </a:r>
           </a:p>
           <a:p>
@@ -6381,6 +6722,14 @@
               <a:buFont typeface="Arial" panose="020B0604020202020204" pitchFamily="34" charset="0"/>
               <a:buChar char="•"/>
             </a:pPr>
+            <a:r>
+              <a:rPr lang="en-US" altLang="en-US" dirty="0" err="1" sz="1100">
+                <a:solidFill>
+                  <a:schemeClr val="tx1"/>
+                </a:solidFill>
+              </a:rPr>
+              <a:t>• Классические: ARIMA, ETS, Prophet, Seasonal Naive</a:t>
+            </a:r>
           </a:p>
           <a:p>
             <a:pPr marL="285750" lvl="0" indent="-285750" eaLnBrk="0" fontAlgn="base" hangingPunct="0">
@@ -6397,12 +6746,12 @@
               <a:buChar char="•"/>
             </a:pPr>
             <a:r>
-              <a:rPr lang="en-US" altLang="en-US" dirty="0" err="1">
+              <a:rPr lang="en-US" altLang="en-US" dirty="0" err="1" sz="1100">
                 <a:solidFill>
                   <a:schemeClr val="tx1"/>
                 </a:solidFill>
               </a:rPr>
-              <a:t>Сравнение проведено на 180 рядах из M3 и M4 Competition по 6 метрикам (sMAPE, MAPE, RMSE, MSE, MAE, MASE).</a:t>
+              <a:t>• Нейросетевые с обучаемой декомпозицией:</a:t>
             </a:r>
           </a:p>
           <a:p>
@@ -6419,6 +6768,14 @@
               <a:buFont typeface="Arial" panose="020B0604020202020204" pitchFamily="34" charset="0"/>
               <a:buChar char="•"/>
             </a:pPr>
+            <a:r>
+              <a:rPr lang="en-US" altLang="en-US" dirty="0" err="1" sz="1100">
+                <a:solidFill>
+                  <a:schemeClr val="tx1"/>
+                </a:solidFill>
+              </a:rPr>
+              <a:t xml:space="preserve">   DLinear, N-BEATS, Autoformer, FEDformer</a:t>
+            </a:r>
           </a:p>
           <a:p>
             <a:pPr marL="285750" lvl="0" indent="-285750" eaLnBrk="0" fontAlgn="base" hangingPunct="0">
@@ -6435,12 +6792,12 @@
               <a:buChar char="•"/>
             </a:pPr>
             <a:r>
-              <a:rPr lang="en-US" altLang="en-US" dirty="0" err="1">
+              <a:rPr lang="en-US" altLang="en-US" dirty="0" err="1" sz="1100">
                 <a:solidFill>
                   <a:schemeClr val="tx1"/>
                 </a:solidFill>
               </a:rPr>
-              <a:t>Исследованы три режима оценки: прямой прогноз, итеративное прогнозирование и предобучение трансформеров.</a:t>
+              <a:t>• Нейросетевые без декомпозиции:</a:t>
             </a:r>
           </a:p>
           <a:p>
@@ -6457,6 +6814,14 @@
               <a:buFont typeface="Arial" panose="020B0604020202020204" pitchFamily="34" charset="0"/>
               <a:buChar char="•"/>
             </a:pPr>
+            <a:r>
+              <a:rPr lang="en-US" altLang="en-US" dirty="0" err="1" sz="1100">
+                <a:solidFill>
+                  <a:schemeClr val="tx1"/>
+                </a:solidFill>
+              </a:rPr>
+              <a:t xml:space="preserve">   PatchTST, TimesNet</a:t>
+            </a:r>
           </a:p>
           <a:p>
             <a:pPr marL="285750" lvl="0" indent="-285750" eaLnBrk="0" fontAlgn="base" hangingPunct="0">
@@ -6473,12 +6838,241 @@
               <a:buChar char="•"/>
             </a:pPr>
             <a:r>
-              <a:rPr lang="en-US" altLang="en-US" dirty="0" err="1">
+              <a:rPr lang="en-US" altLang="en-US" dirty="0" err="1" sz="1100">
                 <a:solidFill>
                   <a:schemeClr val="tx1"/>
                 </a:solidFill>
               </a:rPr>
-              <a:t>Helformer (фиксированная декомпозиция + нейросетевая коррекция) показал лучший sMAPE 10,61% на M3.</a:t>
+              <a:t>• Гибридная: Helformer (HW + трансформер)</a:t>
+            </a:r>
+          </a:p>
+          <a:p>
+            <a:pPr marL="285750" lvl="0" indent="-285750" eaLnBrk="0" fontAlgn="base" hangingPunct="0">
+              <a:lnSpc>
+                <a:spcPct val="100000"/>
+              </a:lnSpc>
+              <a:spcBef>
+                <a:spcPct val="0"/>
+              </a:spcBef>
+              <a:spcAft>
+                <a:spcPct val="0"/>
+              </a:spcAft>
+              <a:buFont typeface="Arial" panose="020B0604020202020204" pitchFamily="34" charset="0"/>
+              <a:buChar char="•"/>
+            </a:pPr>
+          </a:p>
+          <a:p>
+            <a:pPr marL="285750" lvl="0" indent="-285750" eaLnBrk="0" fontAlgn="base" hangingPunct="0">
+              <a:lnSpc>
+                <a:spcPct val="100000"/>
+              </a:lnSpc>
+              <a:spcBef>
+                <a:spcPct val="0"/>
+              </a:spcBef>
+              <a:spcAft>
+                <a:spcPct val="0"/>
+              </a:spcAft>
+              <a:buFont typeface="Arial" panose="020B0604020202020204" pitchFamily="34" charset="0"/>
+              <a:buChar char="•"/>
+            </a:pPr>
+            <a:r>
+              <a:rPr lang="en-US" altLang="en-US" dirty="0" err="1" sz="1100">
+                <a:solidFill>
+                  <a:schemeClr val="tx1"/>
+                </a:solidFill>
+              </a:rPr>
+              <a:t>Сравнение на 180 рядах (M3 + M4 Competition)</a:t>
+            </a:r>
+          </a:p>
+          <a:p>
+            <a:pPr marL="285750" lvl="0" indent="-285750" eaLnBrk="0" fontAlgn="base" hangingPunct="0">
+              <a:lnSpc>
+                <a:spcPct val="100000"/>
+              </a:lnSpc>
+              <a:spcBef>
+                <a:spcPct val="0"/>
+              </a:spcBef>
+              <a:spcAft>
+                <a:spcPct val="0"/>
+              </a:spcAft>
+              <a:buFont typeface="Arial" panose="020B0604020202020204" pitchFamily="34" charset="0"/>
+              <a:buChar char="•"/>
+            </a:pPr>
+            <a:r>
+              <a:rPr lang="en-US" altLang="en-US" dirty="0" err="1" sz="1100">
+                <a:solidFill>
+                  <a:schemeClr val="tx1"/>
+                </a:solidFill>
+              </a:rPr>
+              <a:t>по 6 метрикам: sMAPE, MAPE, RMSE, MSE, MAE, MASE</a:t>
+            </a:r>
+          </a:p>
+          <a:p>
+            <a:pPr marL="285750" lvl="0" indent="-285750" eaLnBrk="0" fontAlgn="base" hangingPunct="0">
+              <a:lnSpc>
+                <a:spcPct val="100000"/>
+              </a:lnSpc>
+              <a:spcBef>
+                <a:spcPct val="0"/>
+              </a:spcBef>
+              <a:spcAft>
+                <a:spcPct val="0"/>
+              </a:spcAft>
+              <a:buFont typeface="Arial" panose="020B0604020202020204" pitchFamily="34" charset="0"/>
+              <a:buChar char="•"/>
+            </a:pPr>
+          </a:p>
+          <a:p>
+            <a:pPr marL="285750" lvl="0" indent="-285750" eaLnBrk="0" fontAlgn="base" hangingPunct="0">
+              <a:lnSpc>
+                <a:spcPct val="100000"/>
+              </a:lnSpc>
+              <a:spcBef>
+                <a:spcPct val="0"/>
+              </a:spcBef>
+              <a:spcAft>
+                <a:spcPct val="0"/>
+              </a:spcAft>
+              <a:buFont typeface="Arial" panose="020B0604020202020204" pitchFamily="34" charset="0"/>
+              <a:buChar char="•"/>
+            </a:pPr>
+            <a:r>
+              <a:rPr lang="en-US" altLang="en-US" dirty="0" err="1" sz="1100">
+                <a:solidFill>
+                  <a:schemeClr val="tx1"/>
+                </a:solidFill>
+              </a:rPr>
+              <a:t>Три режима оценки:</a:t>
+            </a:r>
+          </a:p>
+          <a:p>
+            <a:pPr marL="285750" lvl="0" indent="-285750" eaLnBrk="0" fontAlgn="base" hangingPunct="0">
+              <a:lnSpc>
+                <a:spcPct val="100000"/>
+              </a:lnSpc>
+              <a:spcBef>
+                <a:spcPct val="0"/>
+              </a:spcBef>
+              <a:spcAft>
+                <a:spcPct val="0"/>
+              </a:spcAft>
+              <a:buFont typeface="Arial" panose="020B0604020202020204" pitchFamily="34" charset="0"/>
+              <a:buChar char="•"/>
+            </a:pPr>
+            <a:r>
+              <a:rPr lang="en-US" altLang="en-US" dirty="0" err="1" sz="1100">
+                <a:solidFill>
+                  <a:schemeClr val="tx1"/>
+                </a:solidFill>
+              </a:rPr>
+              <a:t>• Прямой прогноз (direct)</a:t>
+            </a:r>
+          </a:p>
+          <a:p>
+            <a:pPr marL="285750" lvl="0" indent="-285750" eaLnBrk="0" fontAlgn="base" hangingPunct="0">
+              <a:lnSpc>
+                <a:spcPct val="100000"/>
+              </a:lnSpc>
+              <a:spcBef>
+                <a:spcPct val="0"/>
+              </a:spcBef>
+              <a:spcAft>
+                <a:spcPct val="0"/>
+              </a:spcAft>
+              <a:buFont typeface="Arial" panose="020B0604020202020204" pitchFamily="34" charset="0"/>
+              <a:buChar char="•"/>
+            </a:pPr>
+            <a:r>
+              <a:rPr lang="en-US" altLang="en-US" dirty="0" err="1" sz="1100">
+                <a:solidFill>
+                  <a:schemeClr val="tx1"/>
+                </a:solidFill>
+              </a:rPr>
+              <a:t>• Итеративный прогноз (rollout)</a:t>
+            </a:r>
+          </a:p>
+          <a:p>
+            <a:pPr marL="285750" lvl="0" indent="-285750" eaLnBrk="0" fontAlgn="base" hangingPunct="0">
+              <a:lnSpc>
+                <a:spcPct val="100000"/>
+              </a:lnSpc>
+              <a:spcBef>
+                <a:spcPct val="0"/>
+              </a:spcBef>
+              <a:spcAft>
+                <a:spcPct val="0"/>
+              </a:spcAft>
+              <a:buFont typeface="Arial" panose="020B0604020202020204" pitchFamily="34" charset="0"/>
+              <a:buChar char="•"/>
+            </a:pPr>
+            <a:r>
+              <a:rPr lang="en-US" altLang="en-US" dirty="0" err="1" sz="1100">
+                <a:solidFill>
+                  <a:schemeClr val="tx1"/>
+                </a:solidFill>
+              </a:rPr>
+              <a:t>• Предобучение трансформеров (pretrain)</a:t>
+            </a:r>
+          </a:p>
+          <a:p>
+            <a:pPr marL="285750" lvl="0" indent="-285750" eaLnBrk="0" fontAlgn="base" hangingPunct="0">
+              <a:lnSpc>
+                <a:spcPct val="100000"/>
+              </a:lnSpc>
+              <a:spcBef>
+                <a:spcPct val="0"/>
+              </a:spcBef>
+              <a:spcAft>
+                <a:spcPct val="0"/>
+              </a:spcAft>
+              <a:buFont typeface="Arial" panose="020B0604020202020204" pitchFamily="34" charset="0"/>
+              <a:buChar char="•"/>
+            </a:pPr>
+          </a:p>
+          <a:p>
+            <a:pPr marL="285750" lvl="0" indent="-285750" eaLnBrk="0" fontAlgn="base" hangingPunct="0">
+              <a:lnSpc>
+                <a:spcPct val="100000"/>
+              </a:lnSpc>
+              <a:spcBef>
+                <a:spcPct val="0"/>
+              </a:spcBef>
+              <a:spcAft>
+                <a:spcPct val="0"/>
+              </a:spcAft>
+              <a:buFont typeface="Arial" panose="020B0604020202020204" pitchFamily="34" charset="0"/>
+              <a:buChar char="•"/>
+            </a:pPr>
+            <a:r>
+              <a:rPr lang="en-US" altLang="en-US" dirty="0" err="1" sz="1100">
+                <a:solidFill>
+                  <a:schemeClr val="tx1"/>
+                </a:solidFill>
+              </a:rPr>
+              <a:t>Главный результат: Helformer — лучшая модель</a:t>
+            </a:r>
+          </a:p>
+          <a:p>
+            <a:pPr marL="285750" lvl="0" indent="-285750" eaLnBrk="0" fontAlgn="base" hangingPunct="0">
+              <a:lnSpc>
+                <a:spcPct val="100000"/>
+              </a:lnSpc>
+              <a:spcBef>
+                <a:spcPct val="0"/>
+              </a:spcBef>
+              <a:spcAft>
+                <a:spcPct val="0"/>
+              </a:spcAft>
+              <a:buFont typeface="Arial" panose="020B0604020202020204" pitchFamily="34" charset="0"/>
+              <a:buChar char="•"/>
+            </a:pPr>
+            <a:r>
+              <a:rPr lang="en-US" altLang="en-US" dirty="0" err="1" sz="1100">
+                <a:solidFill>
+                  <a:schemeClr val="tx1"/>
+                </a:solidFill>
+              </a:rPr>
+              <a:t>на M3 (sMAPE 10,61%, MASE 0,94)</a:t>
             </a:r>
           </a:p>
         </p:txBody>
@@ -6600,7 +7194,7 @@
               <a:tabLst/>
             </a:pPr>
             <a:r>
-              <a:rPr kumimoji="0" lang="en-US" altLang="en-US" i="0" u="none" strike="noStrike" cap="none" normalizeH="0" baseline="0" dirty="0" err="1">
+              <a:rPr kumimoji="0" lang="en-US" altLang="en-US" i="0" u="none" strike="noStrike" cap="none" normalizeH="0" baseline="0" dirty="0" err="1" sz="1100">
                 <a:ln>
                   <a:noFill/>
                 </a:ln>
@@ -6609,7 +7203,7 @@
                 </a:solidFill>
                 <a:effectLst/>
               </a:rPr>
-              <a:t>Временные ряды являются основным инструментом моделирования процессов в экономике, энергетике, транспорте и финансах. Классические статистические модели (ARIMA, ETS) требуют ручной настройки и теряют качество при нарушении стационарности.</a:t>
+              <a:t>Временные ряды являются основным инструментом моделирования динамических процессов в экономике, энергетике, транспорте и финансах. Точность прогноза напрямую определяет качество планирования ресурсов и оценки рисков.</a:t>
             </a:r>
           </a:p>
           <a:p>
@@ -6648,7 +7242,7 @@
               <a:tabLst/>
             </a:pPr>
             <a:r>
-              <a:rPr kumimoji="0" lang="en-US" altLang="en-US" i="0" u="none" strike="noStrike" cap="none" normalizeH="0" baseline="0" dirty="0" err="1">
+              <a:rPr kumimoji="0" lang="en-US" altLang="en-US" i="0" u="none" strike="noStrike" cap="none" normalizeH="0" baseline="0" dirty="0" err="1" sz="1100">
                 <a:ln>
                   <a:noFill/>
                 </a:ln>
@@ -6657,7 +7251,7 @@
                 </a:solidFill>
                 <a:effectLst/>
               </a:rPr>
-              <a:t>Современные нейросетевые архитектуры на основе трансформеров (Autoformer, FEDformer, PatchTST) обещают лучше захватывать долгосрочные зависимости, однако их эффективность критически зависит от способа декомпозиции входного ряда.</a:t>
+              <a:t>Классические модели (ARIMA, ETS) хорошо изучены, но требуют ручной настройки и плохо обрабатывают нестационарность.</a:t>
             </a:r>
           </a:p>
           <a:p>
@@ -6696,7 +7290,7 @@
               <a:tabLst/>
             </a:pPr>
             <a:r>
-              <a:rPr kumimoji="0" lang="en-US" altLang="en-US" i="0" u="none" strike="noStrike" cap="none" normalizeH="0" baseline="0" dirty="0" err="1">
+              <a:rPr kumimoji="0" lang="en-US" altLang="en-US" i="0" u="none" strike="noStrike" cap="none" normalizeH="0" baseline="0" dirty="0" err="1" sz="1100">
                 <a:ln>
                   <a:noFill/>
                 </a:ln>
@@ -6705,7 +7299,55 @@
                 </a:solidFill>
                 <a:effectLst/>
               </a:rPr>
-              <a:t>Актуален вопрос: при каких условиях обучаемая декомпозиция и нейросетевые механизмы действительно улучшают прогноз, а при каких более простые подходы предпочтительнее?</a:t>
+              <a:t>Нейросетевые трансформеры (Autoformer, FEDformer, PatchTST) внедряют обучаемую декомпозицию ряда на тренд и сезонность непосредственно внутри архитектуры, однако их эффективность зависит от длины ряда и режима обучения.</a:t>
+            </a:r>
+          </a:p>
+          <a:p>
+            <a:pPr marL="285750" marR="0" lvl="0" indent="-285750" algn="l" defTabSz="914400" rtl="0" eaLnBrk="0" fontAlgn="base" latinLnBrk="0" hangingPunct="0">
+              <a:lnSpc>
+                <a:spcPct val="100000"/>
+              </a:lnSpc>
+              <a:spcBef>
+                <a:spcPct val="0"/>
+              </a:spcBef>
+              <a:spcAft>
+                <a:spcPct val="0"/>
+              </a:spcAft>
+              <a:buClrTx/>
+              <a:buSzTx/>
+              <a:buFont typeface="Arial" panose="020B0604020202020204" pitchFamily="34" charset="0"/>
+              <a:buChar char="•"/>
+              <a:tabLst/>
+            </a:pPr>
+          </a:p>
+          <a:p>
+            <a:pPr marL="285750" marR="0" lvl="0" indent="-285750" algn="l" defTabSz="914400" rtl="0" eaLnBrk="0" fontAlgn="base" latinLnBrk="0" hangingPunct="0">
+              <a:lnSpc>
+                <a:spcPct val="100000"/>
+              </a:lnSpc>
+              <a:spcBef>
+                <a:spcPct val="0"/>
+              </a:spcBef>
+              <a:spcAft>
+                <a:spcPct val="0"/>
+              </a:spcAft>
+              <a:buClrTx/>
+              <a:buSzTx/>
+              <a:buFont typeface="Arial" panose="020B0604020202020204" pitchFamily="34" charset="0"/>
+              <a:buChar char="•"/>
+              <a:tabLst/>
+            </a:pPr>
+            <a:r>
+              <a:rPr kumimoji="0" lang="en-US" altLang="en-US" i="0" u="none" strike="noStrike" cap="none" normalizeH="0" baseline="0" dirty="0" err="1" sz="1100">
+                <a:ln>
+                  <a:noFill/>
+                </a:ln>
+                <a:solidFill>
+                  <a:schemeClr val="tx1"/>
+                </a:solidFill>
+                <a:effectLst/>
+              </a:rPr>
+              <a:t>Центральный вопрос: когда обучаемая декомпозиция эффективнее фиксированной статистической, и при каких условиях гибридный подход (Helformer) оказывается лучшим?</a:t>
             </a:r>
           </a:p>
         </p:txBody>
@@ -6837,8 +7479,8 @@
               <a:buChar char="•"/>
             </a:pPr>
             <a:r>
-              <a:rPr lang="ru-RU" dirty="0"/>
-              <a:t>Проведено систематическое сравнение фиксированной и обучаемой декомпозиции временных рядов на 180 рядах из M3 и M4 Competition с участием 11 моделей.</a:t>
+              <a:rPr lang="ru-RU" dirty="0" sz="1100"/>
+              <a:t>1. Проведено систематическое сравнение фиксированной и обучаемой декомпозиции на 180 рядах M3/M4 с участием 11 моделей — крупнейшее в данной постановке.</a:t>
             </a:r>
           </a:p>
           <a:p>
@@ -6853,8 +7495,8 @@
               <a:buChar char="•"/>
             </a:pPr>
             <a:r>
-              <a:rPr lang="ru-RU" dirty="0"/>
-              <a:t>Установлено, что гибридный подход Helformer (фиксированная декомпозиция Хольта–Уинтерса + нейросетевая коррекция) превосходит как чисто статистические, так и чисто нейросетевые методы.</a:t>
+              <a:rPr lang="ru-RU" dirty="0" sz="1100"/>
+              <a:t>2. Helformer (HW-декомпозиция + трансформер) превосходит все чисто нейросетевые модели:</a:t>
             </a:r>
           </a:p>
           <a:p>
@@ -6862,6 +7504,10 @@
               <a:buFont typeface="Arial" panose="020B0604020202020204" pitchFamily="34" charset="0"/>
               <a:buChar char="•"/>
             </a:pPr>
+            <a:r>
+              <a:rPr lang="ru-RU" dirty="0" sz="1100"/>
+              <a:t xml:space="preserve">   • sMAPE 10,61% vs 13,89% у ETS</a:t>
+            </a:r>
           </a:p>
           <a:p>
             <a:pPr marL="285750" indent="-285750">
@@ -6869,8 +7515,8 @@
               <a:buChar char="•"/>
             </a:pPr>
             <a:r>
-              <a:rPr lang="ru-RU" dirty="0"/>
-              <a:t>Выявлена граница ~50–100 наблюдений, ниже которой нейросети уступают классическим моделям.</a:t>
+              <a:rPr lang="ru-RU" dirty="0" sz="1100"/>
+              <a:t xml:space="preserve">   • sMAPE 10,61% vs 17,87% у TimesNet</a:t>
             </a:r>
           </a:p>
           <a:p>
@@ -6878,15 +7524,41 @@
               <a:buFont typeface="Arial" panose="020B0604020202020204" pitchFamily="34" charset="0"/>
               <a:buChar char="•"/>
             </a:pPr>
+            <a:r>
+              <a:rPr lang="ru-RU" dirty="0" sz="1100"/>
+              <a:t xml:space="preserve">   • MASE 0,94 vs 1,47 у ETS</a:t>
+            </a:r>
           </a:p>
           <a:p>
             <a:pPr marL="285750" indent="-285750">
               <a:buFont typeface="Arial" panose="020B0604020202020204" pitchFamily="34" charset="0"/>
               <a:buChar char="•"/>
             </a:pPr>
-            <a:r>
-              <a:rPr lang="ru-RU" dirty="0"/>
-              <a:t>Показано, что предобучение трансформеров на корпусе рядов даёт улучшение на 7–11% sMAPE.</a:t>
+          </a:p>
+          <a:p>
+            <a:pPr marL="285750" indent="-285750">
+              <a:buFont typeface="Arial" panose="020B0604020202020204" pitchFamily="34" charset="0"/>
+              <a:buChar char="•"/>
+            </a:pPr>
+            <a:r>
+              <a:rPr lang="ru-RU" dirty="0" sz="1100"/>
+              <a:t>3. Выявлена граница ~50–100 наблюдений: ниже неё нейросети уступают статистике.</a:t>
+            </a:r>
+          </a:p>
+          <a:p>
+            <a:pPr marL="285750" indent="-285750">
+              <a:buFont typeface="Arial" panose="020B0604020202020204" pitchFamily="34" charset="0"/>
+              <a:buChar char="•"/>
+            </a:pPr>
+          </a:p>
+          <a:p>
+            <a:pPr marL="285750" indent="-285750">
+              <a:buFont typeface="Arial" panose="020B0604020202020204" pitchFamily="34" charset="0"/>
+              <a:buChar char="•"/>
+            </a:pPr>
+            <a:r>
+              <a:rPr lang="ru-RU" dirty="0" sz="1100"/>
+              <a:t>4. Предобучение трансформеров на корпусе рядов даёт +7–11% sMAPE.</a:t>
             </a:r>
           </a:p>
         </p:txBody>
@@ -6931,12 +7603,12 @@
               <a:buChar char="•"/>
             </a:pPr>
             <a:r>
-              <a:rPr lang="en-US" altLang="en-US" dirty="0" err="1">
+              <a:rPr lang="en-US" altLang="en-US" dirty="0" err="1" sz="1100">
                 <a:solidFill>
                   <a:schemeClr val="tx1"/>
                 </a:solidFill>
               </a:rPr>
-              <a:t>Разработан воспроизводимый программный стенд на Python (PyTorch), позволяющий сравнивать произвольные модели на стандартных бенчмарках с единым протоколом.</a:t>
+              <a:t>Воспроизводимый программный стенд на Python/PyTorch с модульной архитектурой: фабрики моделей, JSON-конфиги, чекпоинтирование, GPU-поддержка.</a:t>
             </a:r>
           </a:p>
           <a:p>
@@ -6969,12 +7641,12 @@
               <a:buChar char="•"/>
             </a:pPr>
             <a:r>
-              <a:rPr lang="en-US" altLang="en-US" dirty="0" err="1">
+              <a:rPr lang="en-US" altLang="en-US" dirty="0" err="1" sz="1100">
                 <a:solidFill>
                   <a:schemeClr val="tx1"/>
                 </a:solidFill>
               </a:rPr>
-              <a:t>Результаты применимы для выбора оптимальной стратегии прогнозирования в зависимости от длины ряда и типа данных.</a:t>
+              <a:t>Практические рекомендации по выбору модели:</a:t>
             </a:r>
           </a:p>
           <a:p>
@@ -6991,6 +7663,14 @@
               <a:buFont typeface="Arial" panose="020B0604020202020204" pitchFamily="34" charset="0"/>
               <a:buChar char="•"/>
             </a:pPr>
+            <a:r>
+              <a:rPr lang="en-US" altLang="en-US" dirty="0" err="1" sz="1100">
+                <a:solidFill>
+                  <a:schemeClr val="tx1"/>
+                </a:solidFill>
+              </a:rPr>
+              <a:t>• Короткие ряды с сезонностью → Helformer</a:t>
+            </a:r>
           </a:p>
           <a:p>
             <a:pPr marL="285750" lvl="0" indent="-285750" eaLnBrk="0" fontAlgn="base" hangingPunct="0">
@@ -7007,12 +7687,96 @@
               <a:buChar char="•"/>
             </a:pPr>
             <a:r>
-              <a:rPr lang="en-US" altLang="en-US" dirty="0" err="1">
+              <a:rPr lang="en-US" altLang="en-US" dirty="0" err="1" sz="1100">
                 <a:solidFill>
                   <a:schemeClr val="tx1"/>
                 </a:solidFill>
               </a:rPr>
-              <a:t>Рекомендации: для коротких рядов с сезонностью оптимален гибридный подход Helformer, для длинных — DLinear или N-BEATS.</a:t>
+              <a:t>• Длинные ряды (&gt;100 точек) → DLinear или N-BEATS</a:t>
+            </a:r>
+          </a:p>
+          <a:p>
+            <a:pPr marL="285750" lvl="0" indent="-285750" eaLnBrk="0" fontAlgn="base" hangingPunct="0">
+              <a:lnSpc>
+                <a:spcPct val="100000"/>
+              </a:lnSpc>
+              <a:spcBef>
+                <a:spcPct val="0"/>
+              </a:spcBef>
+              <a:spcAft>
+                <a:spcPct val="0"/>
+              </a:spcAft>
+              <a:buFont typeface="Arial" panose="020B0604020202020204" pitchFamily="34" charset="0"/>
+              <a:buChar char="•"/>
+            </a:pPr>
+            <a:r>
+              <a:rPr lang="en-US" altLang="en-US" dirty="0" err="1" sz="1100">
+                <a:solidFill>
+                  <a:schemeClr val="tx1"/>
+                </a:solidFill>
+              </a:rPr>
+              <a:t>• Средние ряды → ETS или TimesNet</a:t>
+            </a:r>
+          </a:p>
+          <a:p>
+            <a:pPr marL="285750" lvl="0" indent="-285750" eaLnBrk="0" fontAlgn="base" hangingPunct="0">
+              <a:lnSpc>
+                <a:spcPct val="100000"/>
+              </a:lnSpc>
+              <a:spcBef>
+                <a:spcPct val="0"/>
+              </a:spcBef>
+              <a:spcAft>
+                <a:spcPct val="0"/>
+              </a:spcAft>
+              <a:buFont typeface="Arial" panose="020B0604020202020204" pitchFamily="34" charset="0"/>
+              <a:buChar char="•"/>
+            </a:pPr>
+            <a:r>
+              <a:rPr lang="en-US" altLang="en-US" dirty="0" err="1" sz="1100">
+                <a:solidFill>
+                  <a:schemeClr val="tx1"/>
+                </a:solidFill>
+              </a:rPr>
+              <a:t>• При наличии корпуса → предобучение трансформеров</a:t>
+            </a:r>
+          </a:p>
+          <a:p>
+            <a:pPr marL="285750" lvl="0" indent="-285750" eaLnBrk="0" fontAlgn="base" hangingPunct="0">
+              <a:lnSpc>
+                <a:spcPct val="100000"/>
+              </a:lnSpc>
+              <a:spcBef>
+                <a:spcPct val="0"/>
+              </a:spcBef>
+              <a:spcAft>
+                <a:spcPct val="0"/>
+              </a:spcAft>
+              <a:buFont typeface="Arial" panose="020B0604020202020204" pitchFamily="34" charset="0"/>
+              <a:buChar char="•"/>
+            </a:pPr>
+          </a:p>
+          <a:p>
+            <a:pPr marL="285750" lvl="0" indent="-285750" eaLnBrk="0" fontAlgn="base" hangingPunct="0">
+              <a:lnSpc>
+                <a:spcPct val="100000"/>
+              </a:lnSpc>
+              <a:spcBef>
+                <a:spcPct val="0"/>
+              </a:spcBef>
+              <a:spcAft>
+                <a:spcPct val="0"/>
+              </a:spcAft>
+              <a:buFont typeface="Arial" panose="020B0604020202020204" pitchFamily="34" charset="0"/>
+              <a:buChar char="•"/>
+            </a:pPr>
+            <a:r>
+              <a:rPr lang="en-US" altLang="en-US" dirty="0" err="1" sz="1100">
+                <a:solidFill>
+                  <a:schemeClr val="tx1"/>
+                </a:solidFill>
+              </a:rPr>
+              <a:t>Результаты применимы к прогнозированию в финансах, энергетике, логистике, городской инфраструктуре.</a:t>
             </a:r>
           </a:p>
         </p:txBody>
@@ -7107,59 +7871,53 @@
           <a:lstStyle/>
           <a:p>
             <a:r>
-              <a:rPr lang="ru" sz="1600" dirty="0"/>
-              <a:t>Исследование посвящено сравнительному анализу подходов к прогнозированию одномерных временных рядов с акцентом на роли декомпозиции в нейросетевых архитектурах.</a:t>
+              <a:rPr lang="ru" sz="1000" dirty="0"/>
+              <a:t>Отличие фиксированной и обучаемой декомпозиции:</a:t>
             </a:r>
           </a:p>
           <a:p/>
           <a:p>
             <a:r>
-              <a:rPr lang="ru" sz="1600" dirty="0"/>
-              <a:t>Центральный вопрос: в каких условиях обучаемая декомпозиция (DLinear, Autoformer, N-BEATS) эффективнее фиксированной (ETS, Helformer), и наоборот.</a:t>
+              <a:rPr lang="ru" sz="1000" dirty="0"/>
+              <a:t>Фиксированная декомпозиция (ETS, Helformer): ряд разлагается методом Хольта–Уинтерса на тренд, сезонность и остаток ДО подачи в нейросеть. Параметры декомпозиции определяются статистически, нейросеть обрабатывает только остатки.</a:t>
             </a:r>
           </a:p>
           <a:p/>
           <a:p>
             <a:r>
-              <a:rPr lang="ru" sz="1600" dirty="0"/>
-              <a:t>Экспериментальная база: 90 рядов M3 (годовые, квартальные, месячные) и 90 рядов M4 (квартальные, месячные, ежедневные) — всего 180 рядов с горизонтами от 6 до 18 шагов.</a:t>
+              <a:rPr lang="ru" sz="1000" dirty="0"/>
+              <a:t>Обучаемая декомпозиция (Autoformer, DLinear): декомпозиция встроена в саму нейросеть. Autoformer выполняет progressive decomposition на каждом слое энкодера через скользящее среднее, а DLinear использует обучаемое ядро для разделения тренда и остатка с последующей линейной проекцией.</a:t>
             </a:r>
           </a:p>
           <a:p/>
           <a:p>
             <a:r>
-              <a:rPr lang="ru" sz="1600" dirty="0"/>
-              <a:t>Ключевые результаты:</a:t>
-            </a:r>
-          </a:p>
-          <a:p>
-            <a:r>
-              <a:rPr lang="ru" sz="1600" dirty="0"/>
-              <a:t>• Helformer — лучшая модель на M3 (sMAPE 10,61%, MASE 0,94)</a:t>
-            </a:r>
-          </a:p>
-          <a:p>
-            <a:r>
-              <a:rPr lang="ru" sz="1600" dirty="0"/>
-              <a:t>• ETS — лучшая среди статистических (sMAPE 13,89%)</a:t>
-            </a:r>
-          </a:p>
-          <a:p>
-            <a:r>
-              <a:rPr lang="ru" sz="1600" dirty="0"/>
-              <a:t>• DLinear — лучший на ежедневных рядах M4 (sMAPE 2,43%)</a:t>
-            </a:r>
-          </a:p>
-          <a:p>
-            <a:r>
-              <a:rPr lang="ru" sz="1600" dirty="0"/>
-              <a:t>• Предобучение улучшает трансформеры на 7–11%</a:t>
-            </a:r>
-          </a:p>
-          <a:p>
-            <a:r>
-              <a:rPr lang="ru" sz="1600" dirty="0"/>
-              <a:t>• Autoformer и FEDformer наименее устойчивы при итеративном прогнозе</a:t>
+              <a:rPr lang="ru" sz="1000" dirty="0"/>
+              <a:t>Протокол эксперимента:</a:t>
+            </a:r>
+          </a:p>
+          <a:p>
+            <a:r>
+              <a:rPr lang="ru" sz="1000" dirty="0"/>
+              <a:t>• Per-series обучение: каждая нейросеть обучается отдельно на каждом ряде (80 эпох, AdamW, z-score нормализация)</a:t>
+            </a:r>
+          </a:p>
+          <a:p>
+            <a:r>
+              <a:rPr lang="ru" sz="1000" dirty="0"/>
+              <a:t>• M3: 90 рядов (30 yearly H=6, 30 quarterly H=8, 30 monthly H=18)</a:t>
+            </a:r>
+          </a:p>
+          <a:p>
+            <a:r>
+              <a:rPr lang="ru" sz="1000" dirty="0"/>
+              <a:t>• M4: 90 рядов (30 quarterly H=8, 30 monthly H=18, 30 daily H=14)</a:t>
+            </a:r>
+          </a:p>
+          <a:p>
+            <a:r>
+              <a:rPr lang="ru" sz="1000" dirty="0"/>
+              <a:t>• Seed=42, GPU RTX A4000, воспроизводимые конфигурации</a:t>
             </a:r>
           </a:p>
         </p:txBody>
@@ -7192,7 +7950,7 @@
           <a:p>
             <a:r>
               <a:rPr lang="ru-RU" dirty="0"/>
-              <a:t>Описание проекта</a:t>
+              <a:t>Методология исследования</a:t>
             </a:r>
           </a:p>
         </p:txBody>
@@ -7518,7 +8276,7 @@
                       </a:r>
                       <a:r>
                         <a:rPr lang="en-US" dirty="0"/>
-                        <a:t>, </a:t>
+                        <a:t xml:space="preserve">, </a:t>
                       </a:r>
                       <a:r>
                         <a:rPr lang="en-US" dirty="0" err="1"/>
@@ -7526,7 +8284,7 @@
                       </a:r>
                       <a:r>
                         <a:rPr lang="en-US" dirty="0"/>
-                        <a:t>, </a:t>
+                        <a:t xml:space="preserve">, </a:t>
                       </a:r>
                       <a:r>
                         <a:rPr lang="en-US" dirty="0" err="1"/>
@@ -7584,7 +8342,7 @@
                       <a:pPr algn="l"/>
                       <a:r>
                         <a:rPr lang="ru" dirty="0"/>
-                        <a:t>Настройка и сравнение различных схем декомпозиции временных рядов для архитектуры </a:t>
+                        <a:t xml:space="preserve">Настройка и сравнение различных схем декомпозиции временных рядов для архитектуры </a:t>
                       </a:r>
                       <a:r>
                         <a:rPr lang="en-US" dirty="0" err="1"/>
@@ -7592,7 +8350,7 @@
                       </a:r>
                       <a:r>
                         <a:rPr lang="en-US" dirty="0"/>
-                        <a:t>, </a:t>
+                        <a:t xml:space="preserve">, </a:t>
                       </a:r>
                       <a:r>
                         <a:rPr lang="ru" dirty="0"/>
@@ -7647,15 +8405,15 @@
                       <a:pPr algn="l"/>
                       <a:r>
                         <a:rPr lang="ru" dirty="0"/>
-                        <a:t>Проведение серии экспериментов на наборах </a:t>
+                        <a:t xml:space="preserve">Проведение серии экспериментов на наборах </a:t>
                       </a:r>
                       <a:r>
                         <a:rPr lang="en-US" dirty="0"/>
-                        <a:t>M3–M4–M5, </a:t>
+                        <a:t xml:space="preserve">M3–M4–M5, </a:t>
                       </a:r>
                       <a:r>
                         <a:rPr lang="ru" dirty="0"/>
-                        <a:t>сравнение моделей по метрикам </a:t>
+                        <a:t xml:space="preserve">сравнение моделей по метрикам </a:t>
                       </a:r>
                       <a:r>
                         <a:rPr lang="en-US" dirty="0" err="1"/>
@@ -7872,12 +8630,12 @@
               </a:spcAft>
             </a:pPr>
             <a:r>
-              <a:rPr lang="en-US" altLang="en-US" sz="1600" dirty="0" err="1">
+              <a:rPr lang="en-US" altLang="en-US" sz="1000" dirty="0" err="1">
                 <a:solidFill>
                   <a:schemeClr val="tx1"/>
                 </a:solidFill>
               </a:rPr>
-              <a:t>На основании проведённых экспериментов сформулированы следующие выводы.</a:t>
+              <a:t>1. Гибридная модель Helformer (фиксированная декомпозиция Хольта–Уинтерса + трансформерная коррекция остатков) — лучшая модель среди всех 11 протестированных на M3 Competition (sMAPE 10,61%, MASE 0,94, средний ранг 2,00).</a:t>
             </a:r>
           </a:p>
           <a:p>
@@ -7906,12 +8664,12 @@
               </a:spcAft>
             </a:pPr>
             <a:r>
-              <a:rPr lang="en-US" altLang="en-US" sz="1600" dirty="0" err="1">
+              <a:rPr lang="en-US" altLang="en-US" sz="1000" dirty="0" err="1">
                 <a:solidFill>
                   <a:schemeClr val="tx1"/>
                 </a:solidFill>
               </a:rPr>
-              <a:t>1. Helformer (фиксированная декомпозиция Хольта–Уинтерса + трансформерная коррекция) — лучшая модель на M3 (sMAPE 10,61%, средний ранг 2,00 из 11).</a:t>
+              <a:t>2. Длина обучающей выборки — критический фактор: при менее 50 наблюдениях все нейросети уступают ETS и ARIMA; при более 100 — DLinear и N-BEATS конкурируют и побеждают.</a:t>
             </a:r>
           </a:p>
           <a:p>
@@ -7940,12 +8698,12 @@
               </a:spcAft>
             </a:pPr>
             <a:r>
-              <a:rPr lang="en-US" altLang="en-US" sz="1600" dirty="0" err="1">
+              <a:rPr lang="en-US" altLang="en-US" sz="1000" dirty="0" err="1">
                 <a:solidFill>
                   <a:schemeClr val="tx1"/>
                 </a:solidFill>
               </a:rPr>
-              <a:t>2. Длина ряда — критический фактор: при менее 50 наблюдениях нейросети уступают ETS и ARIMA; при более 100 — конкурируют.</a:t>
+              <a:t>3. Обучаемая декомпозиция трансформерного типа (Autoformer, FEDformer) в per-series режиме показала наихудшие результаты (sMAPE 22–34%). Простая обучаемая декомпозиция (DLinear) эффективна только на длинных рядах.</a:t>
             </a:r>
           </a:p>
           <a:p>
@@ -7974,12 +8732,12 @@
               </a:spcAft>
             </a:pPr>
             <a:r>
-              <a:rPr lang="en-US" altLang="en-US" sz="1600" dirty="0" err="1">
+              <a:rPr lang="en-US" altLang="en-US" sz="1000" dirty="0" err="1">
                 <a:solidFill>
                   <a:schemeClr val="tx1"/>
                 </a:solidFill>
               </a:rPr>
-              <a:t>3. Обучаемая декомпозиция (DLinear, N-BEATS) эффективна на длинных рядах: DLinear — лучший на M4 daily (sMAPE 2,43%).</a:t>
+              <a:t>4. Предобучение трансформеров на корпусе рядов улучшает sMAPE на 7–11%, частично компенсируя дефицит данных при per-series обучении.</a:t>
             </a:r>
           </a:p>
           <a:p>
@@ -8008,46 +8766,12 @@
               </a:spcAft>
             </a:pPr>
             <a:r>
-              <a:rPr lang="en-US" altLang="en-US" sz="1600" dirty="0" err="1">
+              <a:rPr lang="en-US" altLang="en-US" sz="1000" dirty="0" err="1">
                 <a:solidFill>
                   <a:schemeClr val="tx1"/>
                 </a:solidFill>
               </a:rPr>
-              <a:t>4. Предобучение на корпусе рядов улучшает трансформеры на 7–11%, делая их конкурентоспособными.</a:t>
-            </a:r>
-          </a:p>
-          <a:p>
-            <a:pPr lvl="0" eaLnBrk="0" fontAlgn="base" hangingPunct="0">
-              <a:lnSpc>
-                <a:spcPct val="100000"/>
-              </a:lnSpc>
-              <a:spcBef>
-                <a:spcPct val="0"/>
-              </a:spcBef>
-              <a:spcAft>
-                <a:spcPct val="0"/>
-              </a:spcAft>
-            </a:pPr>
-          </a:p>
-          <a:p>
-            <a:pPr lvl="0" eaLnBrk="0" fontAlgn="base" hangingPunct="0">
-              <a:lnSpc>
-                <a:spcPct val="100000"/>
-              </a:lnSpc>
-              <a:spcBef>
-                <a:spcPct val="0"/>
-              </a:spcBef>
-              <a:spcAft>
-                <a:spcPct val="0"/>
-              </a:spcAft>
-            </a:pPr>
-            <a:r>
-              <a:rPr lang="en-US" altLang="en-US" sz="1600" dirty="0" err="1">
-                <a:solidFill>
-                  <a:schemeClr val="tx1"/>
-                </a:solidFill>
-              </a:rPr>
-              <a:t>5. При итеративном прогнозировании модели с обучаемой декомпозицией деградируют сильнее всего (FEDformer +5 п.п.), PatchTST — наиболее устойчивый (+2 п.п.).</a:t>
+              <a:t>5. Итеративное прогнозирование выявляет хрупкость обучаемой декомпозиции: FEDformer деградирует на +6,3 п.п., тогда как PatchTST (без декомпозиции) — наиболее устойчивый (+1,8 п.п.).</a:t>
             </a:r>
           </a:p>
         </p:txBody>
@@ -8138,7 +8862,7 @@
           <a:p>
             <a:r>
               <a:rPr lang="ru-RU" sz="2000" dirty="0"/>
-              <a:t>Построение комбинированных моделей на основе алгоритма </a:t>
+              <a:t xml:space="preserve">Построение комбинированных моделей на основе алгоритма </a:t>
             </a:r>
             <a:r>
               <a:rPr lang="en-US" sz="2000" dirty="0" err="1"/>
@@ -8146,7 +8870,7 @@
             </a:r>
             <a:r>
               <a:rPr lang="en-US" sz="2000" dirty="0"/>
-              <a:t> </a:t>
+              <a:t xml:space="preserve"> </a:t>
             </a:r>
             <a:r>
               <a:rPr lang="ru-RU" sz="2000" dirty="0"/>
@@ -8302,7 +9026,7 @@
                 <a:ea typeface="Roboto Condensed" panose="02000000000000000000" pitchFamily="2" charset="0"/>
                 <a:cs typeface="Calibri" panose="020F0502020204030204" pitchFamily="34" charset="0"/>
               </a:rPr>
-              <a:t> </a:t>
+              <a:t xml:space="preserve"> </a:t>
             </a:r>
             <a:r>
               <a:rPr lang="ru-RU" sz="1800" kern="1200" dirty="0">
@@ -8794,6 +9518,349 @@
         <p14:creationId xmlns:p14="http://schemas.microsoft.com/office/powerpoint/2010/main" val="2511029548"/>
       </p:ext>
     </p:extLst>
+  </p:cSld>
+  <p:clrMapOvr>
+    <a:masterClrMapping/>
+  </p:clrMapOvr>
+</p:sld>
+</file>
+
+<file path=ppt/slides/slide8.xml><?xml version="1.0" encoding="utf-8"?>
+<p:sld xmlns:a="http://schemas.openxmlformats.org/drawingml/2006/main" xmlns:p="http://schemas.openxmlformats.org/presentationml/2006/main" xmlns:r="http://schemas.openxmlformats.org/officeDocument/2006/relationships">
+  <p:cSld>
+    <p:spTree>
+      <p:nvGrpSpPr>
+        <p:cNvPr id="1" name=""/>
+        <p:cNvGrpSpPr/>
+        <p:nvPr/>
+      </p:nvGrpSpPr>
+      <p:grpSpPr/>
+      <p:sp>
+        <p:nvSpPr>
+          <p:cNvPr id="2" name="Title 1"/>
+          <p:cNvSpPr>
+            <a:spLocks noGrp="1"/>
+          </p:cNvSpPr>
+          <p:nvPr>
+            <p:ph type="title"/>
+          </p:nvPr>
+        </p:nvSpPr>
+        <p:spPr/>
+        <p:txBody>
+          <a:bodyPr/>
+          <a:lstStyle/>
+          <a:p>
+            <a:r>
+              <a:rPr lang="ru-RU" dirty="0"/>
+              <a:t>Результаты: кросс-датасетное сравнение</a:t>
+            </a:r>
+          </a:p>
+        </p:txBody>
+      </p:sp>
+      <p:sp>
+        <p:nvSpPr>
+          <p:cNvPr id="3" name="Text Placeholder 2"/>
+          <p:cNvSpPr>
+            <a:spLocks noGrp="1"/>
+          </p:cNvSpPr>
+          <p:nvPr>
+            <p:ph type="body" idx="10" sz="quarter"/>
+          </p:nvPr>
+        </p:nvSpPr>
+        <p:spPr/>
+        <p:txBody>
+          <a:bodyPr/>
+          <a:lstStyle/>
+          <a:p>
+            <a:r>
+              <a:rPr lang="ru-RU" dirty="0"/>
+              <a:t>Основные наблюдения</a:t>
+            </a:r>
+          </a:p>
+        </p:txBody>
+      </p:sp>
+      <p:sp>
+        <p:nvSpPr>
+          <p:cNvPr id="4" name="Text Placeholder 3"/>
+          <p:cNvSpPr>
+            <a:spLocks noGrp="1"/>
+          </p:cNvSpPr>
+          <p:nvPr>
+            <p:ph type="body" idx="11" sz="quarter"/>
+          </p:nvPr>
+        </p:nvSpPr>
+        <p:spPr/>
+        <p:txBody>
+          <a:bodyPr/>
+          <a:lstStyle/>
+          <a:p>
+            <a:r>
+              <a:rPr lang="ru-RU" dirty="0" sz="1100"/>
+              <a:t>Helformer — лучшая модель на M3:</a:t>
+            </a:r>
+          </a:p>
+          <a:p>
+            <a:r>
+              <a:rPr lang="ru-RU" dirty="0" sz="1100"/>
+              <a:t>sMAPE 10,61% (vs 13,89% ETS)</a:t>
+            </a:r>
+          </a:p>
+          <a:p/>
+          <a:p>
+            <a:r>
+              <a:rPr lang="ru-RU" dirty="0" sz="1100"/>
+              <a:t>ETS — лучшая статистическая:</a:t>
+            </a:r>
+          </a:p>
+          <a:p>
+            <a:r>
+              <a:rPr lang="ru-RU" dirty="0" sz="1100"/>
+              <a:t>стабильно top-2 на всех частотах</a:t>
+            </a:r>
+          </a:p>
+          <a:p/>
+          <a:p>
+            <a:r>
+              <a:rPr lang="ru-RU" dirty="0" sz="1100"/>
+              <a:t>DLinear — лучший на M4 daily:</a:t>
+            </a:r>
+          </a:p>
+          <a:p>
+            <a:r>
+              <a:rPr lang="ru-RU" dirty="0" sz="1100"/>
+              <a:t>sMAPE 2,43% (длинные ряды)</a:t>
+            </a:r>
+          </a:p>
+          <a:p/>
+          <a:p>
+            <a:r>
+              <a:rPr lang="ru-RU" dirty="0" sz="1100"/>
+              <a:t>Autoformer, FEDformer —</a:t>
+            </a:r>
+          </a:p>
+          <a:p>
+            <a:r>
+              <a:rPr lang="ru-RU" dirty="0" sz="1100"/>
+              <a:t>слабейшие (sMAPE 22–34%),</a:t>
+            </a:r>
+          </a:p>
+          <a:p>
+            <a:r>
+              <a:rPr lang="ru-RU" dirty="0" sz="1100"/>
+              <a:t>обучаемая decomp не окупается</a:t>
+            </a:r>
+          </a:p>
+          <a:p>
+            <a:r>
+              <a:rPr lang="ru-RU" dirty="0" sz="1100"/>
+              <a:t>при per-series обучении</a:t>
+            </a:r>
+          </a:p>
+        </p:txBody>
+      </p:sp>
+      <p:pic>
+        <p:nvPicPr>
+          <p:cNvPr id="5" name="Picture Placeholder 4" descr="heatmap_smape.png"/>
+          <p:cNvPicPr>
+            <a:picLocks noGrp="1" noChangeAspect="1"/>
+          </p:cNvPicPr>
+          <p:nvPr>
+            <p:ph type="pic" idx="12" sz="quarter"/>
+          </p:nvPr>
+        </p:nvPicPr>
+        <p:blipFill>
+          <a:blip r:embed="rId2"/>
+          <a:srcRect l="28259" r="28259"/>
+          <a:stretch>
+            <a:fillRect/>
+          </a:stretch>
+        </p:blipFill>
+        <p:spPr/>
+      </p:pic>
+    </p:spTree>
+  </p:cSld>
+  <p:clrMapOvr>
+    <a:masterClrMapping/>
+  </p:clrMapOvr>
+</p:sld>
+</file>
+
+<file path=ppt/slides/slide9.xml><?xml version="1.0" encoding="utf-8"?>
+<p:sld xmlns:a="http://schemas.openxmlformats.org/drawingml/2006/main" xmlns:p="http://schemas.openxmlformats.org/presentationml/2006/main" xmlns:r="http://schemas.openxmlformats.org/officeDocument/2006/relationships">
+  <p:cSld>
+    <p:spTree>
+      <p:nvGrpSpPr>
+        <p:cNvPr id="1" name=""/>
+        <p:cNvGrpSpPr/>
+        <p:nvPr/>
+      </p:nvGrpSpPr>
+      <p:grpSpPr/>
+      <p:sp>
+        <p:nvSpPr>
+          <p:cNvPr id="2" name="Title 1"/>
+          <p:cNvSpPr>
+            <a:spLocks noGrp="1"/>
+          </p:cNvSpPr>
+          <p:nvPr>
+            <p:ph type="title"/>
+          </p:nvPr>
+        </p:nvSpPr>
+        <p:spPr/>
+        <p:txBody>
+          <a:bodyPr/>
+          <a:lstStyle/>
+          <a:p>
+            <a:r>
+              <a:rPr lang="ru-RU" dirty="0"/>
+              <a:t>Итеративное прогнозирование (rollout)</a:t>
+            </a:r>
+          </a:p>
+        </p:txBody>
+      </p:sp>
+      <p:sp>
+        <p:nvSpPr>
+          <p:cNvPr id="3" name="Text Placeholder 2"/>
+          <p:cNvSpPr>
+            <a:spLocks noGrp="1"/>
+          </p:cNvSpPr>
+          <p:nvPr>
+            <p:ph type="body" idx="10" sz="quarter"/>
+          </p:nvPr>
+        </p:nvSpPr>
+        <p:spPr/>
+        <p:txBody>
+          <a:bodyPr/>
+          <a:lstStyle/>
+          <a:p>
+            <a:r>
+              <a:rPr lang="ru-RU" dirty="0"/>
+              <a:t>Деградация при rollout</a:t>
+            </a:r>
+          </a:p>
+        </p:txBody>
+      </p:sp>
+      <p:sp>
+        <p:nvSpPr>
+          <p:cNvPr id="4" name="Text Placeholder 3"/>
+          <p:cNvSpPr>
+            <a:spLocks noGrp="1"/>
+          </p:cNvSpPr>
+          <p:nvPr>
+            <p:ph type="body" idx="11" sz="quarter"/>
+          </p:nvPr>
+        </p:nvSpPr>
+        <p:spPr/>
+        <p:txBody>
+          <a:bodyPr/>
+          <a:lstStyle/>
+          <a:p>
+            <a:r>
+              <a:rPr lang="ru-RU" dirty="0" sz="1100"/>
+              <a:t>При итеративном прогнозе модель</a:t>
+            </a:r>
+          </a:p>
+          <a:p>
+            <a:r>
+              <a:rPr lang="ru-RU" dirty="0" sz="1100"/>
+              <a:t>предсказывает по одному шагу,</a:t>
+            </a:r>
+          </a:p>
+          <a:p>
+            <a:r>
+              <a:rPr lang="ru-RU" dirty="0" sz="1100"/>
+              <a:t>используя собственные предсказания</a:t>
+            </a:r>
+          </a:p>
+          <a:p>
+            <a:r>
+              <a:rPr lang="ru-RU" dirty="0" sz="1100"/>
+              <a:t>как входные данные.</a:t>
+            </a:r>
+          </a:p>
+          <a:p/>
+          <a:p>
+            <a:r>
+              <a:rPr lang="ru-RU" dirty="0" sz="1100"/>
+              <a:t>Деградация sMAPE (M3):</a:t>
+            </a:r>
+          </a:p>
+          <a:p>
+            <a:r>
+              <a:rPr lang="ru-RU" dirty="0" sz="1100"/>
+              <a:t>• FEDformer: +6,3 п.п.</a:t>
+            </a:r>
+          </a:p>
+          <a:p>
+            <a:r>
+              <a:rPr lang="ru-RU" dirty="0" sz="1100"/>
+              <a:t>• Autoformer: +4,9 п.п.</a:t>
+            </a:r>
+          </a:p>
+          <a:p>
+            <a:r>
+              <a:rPr lang="ru-RU" dirty="0" sz="1100"/>
+              <a:t>• TimesNet: +4,3 п.п.</a:t>
+            </a:r>
+          </a:p>
+          <a:p>
+            <a:r>
+              <a:rPr lang="ru-RU" dirty="0" sz="1100"/>
+              <a:t>• N-BEATS: +3,9 п.п.</a:t>
+            </a:r>
+          </a:p>
+          <a:p>
+            <a:r>
+              <a:rPr lang="ru-RU" dirty="0" sz="1100"/>
+              <a:t>• PatchTST: +1,8 п.п. (лучший)</a:t>
+            </a:r>
+          </a:p>
+          <a:p>
+            <a:r>
+              <a:rPr lang="ru-RU" dirty="0" sz="1100"/>
+              <a:t>• DLinear: +0,4 п.п.</a:t>
+            </a:r>
+          </a:p>
+          <a:p>
+            <a:r>
+              <a:rPr lang="ru-RU" dirty="0" sz="1100"/>
+              <a:t>• ETS, ARIMA: 0,0 п.п.</a:t>
+            </a:r>
+          </a:p>
+          <a:p/>
+          <a:p>
+            <a:r>
+              <a:rPr lang="ru-RU" dirty="0" sz="1100"/>
+              <a:t>Вывод: сложная обучаемая</a:t>
+            </a:r>
+          </a:p>
+          <a:p>
+            <a:r>
+              <a:rPr lang="ru-RU" dirty="0" sz="1100"/>
+              <a:t>декомпозиция наименее устойчива</a:t>
+            </a:r>
+          </a:p>
+        </p:txBody>
+      </p:sp>
+      <p:pic>
+        <p:nvPicPr>
+          <p:cNvPr id="5" name="Picture Placeholder 4" descr="rollout_m3_quarterly_T478.png"/>
+          <p:cNvPicPr>
+            <a:picLocks noGrp="1" noChangeAspect="1"/>
+          </p:cNvPicPr>
+          <p:nvPr>
+            <p:ph type="pic" idx="12" sz="quarter"/>
+          </p:nvPr>
+        </p:nvPicPr>
+        <p:blipFill>
+          <a:blip r:embed="rId2"/>
+          <a:srcRect l="25975" r="25975"/>
+          <a:stretch>
+            <a:fillRect/>
+          </a:stretch>
+        </p:blipFill>
+        <p:spPr/>
+      </p:pic>
+    </p:spTree>
   </p:cSld>
   <p:clrMapOvr>
     <a:masterClrMapping/>

</xml_diff>